<commit_message>
feat(presentation): capture genuine E2E desktop screenshots, lock final model in FINAL_MODEL_SELECTION.md, and embed live evidence in presentation
</commit_message>
<xml_diff>
--- a/docs/presentation/DentaVision_AI_Final_Presentation.pptx
+++ b/docs/presentation/DentaVision_AI_Final_Presentation.pptx
@@ -19,6 +19,7 @@
     <p:sldId id="267" r:id="rId18"/>
     <p:sldId id="268" r:id="rId19"/>
     <p:sldId id="269" r:id="rId20"/>
+    <p:sldId id="270" r:id="rId21"/>
   </p:sldIdLst>
   <p:sldSz cx="12191695" cy="6858000" type="screen4x3"/>
   <p:notesSz cx="6858000" cy="9144000"/>
@@ -3895,214 +3896,83 @@
               </a:defRPr>
             </a:pPr>
             <a:r>
-              <a:t>Demonstration Flow (Live Viva Walkthrough)</a:t>
-            </a:r>
-          </a:p>
-        </p:txBody>
-      </p:sp>
-      <p:sp>
-        <p:nvSpPr>
-          <p:cNvPr id="5" name="Rounded Rectangle 4"/>
-          <p:cNvSpPr/>
-          <p:nvPr/>
-        </p:nvSpPr>
+              <a:t>Clinical Desktop Application in Action (Live Evidence)</a:t>
+            </a:r>
+          </a:p>
+        </p:txBody>
+      </p:sp>
+      <p:pic>
+        <p:nvPicPr>
+          <p:cNvPr id="5" name="Picture 4" descr="screen_4_live_ai_xray_detection.png"/>
+          <p:cNvPicPr>
+            <a:picLocks noChangeAspect="1"/>
+          </p:cNvPicPr>
+          <p:nvPr/>
+        </p:nvPicPr>
+        <p:blipFill>
+          <a:blip r:embed="rId2"/>
+          <a:stretch>
+            <a:fillRect/>
+          </a:stretch>
+        </p:blipFill>
         <p:spPr>
           <a:xfrm>
             <a:off x="731520" y="1645920"/>
-            <a:ext cx="10698480" cy="4572000"/>
-          </a:xfrm>
-          <a:prstGeom prst="roundRect">
-            <a:avLst/>
-          </a:prstGeom>
-          <a:solidFill>
-            <a:srgbClr val="1E293B"/>
-          </a:solidFill>
-          <a:ln w="12700">
-            <a:solidFill>
-              <a:srgbClr val="334155"/>
-            </a:solidFill>
-          </a:ln>
-        </p:spPr>
-        <p:style>
-          <a:lnRef idx="1">
-            <a:schemeClr val="accent1"/>
-          </a:lnRef>
-          <a:fillRef idx="3">
-            <a:schemeClr val="accent1"/>
-          </a:fillRef>
-          <a:effectRef idx="2">
-            <a:schemeClr val="accent1"/>
-          </a:effectRef>
-          <a:fontRef idx="minor">
-            <a:schemeClr val="lt1"/>
-          </a:fontRef>
-        </p:style>
-        <p:txBody>
-          <a:bodyPr rtlCol="0" anchor="ctr"/>
-          <a:lstStyle/>
-          <a:p>
-            <a:pPr algn="ctr"/>
-          </a:p>
-        </p:txBody>
-      </p:sp>
-      <p:sp>
-        <p:nvSpPr>
-          <p:cNvPr id="6" name="TextBox 5"/>
-          <p:cNvSpPr txBox="1"/>
-          <p:nvPr/>
-        </p:nvSpPr>
-        <p:spPr>
-          <a:xfrm>
-            <a:off x="960120" y="1828800"/>
-            <a:ext cx="10241280" cy="4206240"/>
+            <a:ext cx="5669280" cy="3208247"/>
           </a:xfrm>
           <a:prstGeom prst="rect">
             <a:avLst/>
           </a:prstGeom>
-          <a:noFill/>
-        </p:spPr>
-        <p:txBody>
-          <a:bodyPr wrap="square">
-            <a:spAutoFit/>
-          </a:bodyPr>
-          <a:lstStyle/>
-          <a:p>
-            <a:pPr>
-              <a:spcAft>
-                <a:spcPts val="1000"/>
-              </a:spcAft>
-              <a:defRPr sz="1600" b="1">
-                <a:solidFill>
-                  <a:srgbClr val="06B6D4"/>
-                </a:solidFill>
-              </a:defRPr>
-            </a:pPr>
-            <a:r>
-              <a:t>Step-by-Step Clinical Demo Path</a:t>
-            </a:r>
-          </a:p>
-          <a:p>
-            <a:pPr>
-              <a:spcAft>
-                <a:spcPts val="600"/>
-              </a:spcAft>
-              <a:defRPr sz="1200">
-                <a:solidFill>
-                  <a:srgbClr val="FFFFFF"/>
-                </a:solidFill>
-              </a:defRPr>
-            </a:pPr>
-            <a:r>
-              <a:t>•  Step 1: Receptionist registers patient 'Amina Rahmani' (DOB: 1992-04-14, Medical Flag: Penicillin Allergy).</a:t>
-            </a:r>
-          </a:p>
-          <a:p>
-            <a:pPr>
-              <a:spcAft>
-                <a:spcPts val="600"/>
-              </a:spcAft>
-              <a:defRPr sz="1200">
-                <a:solidFill>
-                  <a:srgbClr val="FFFFFF"/>
-                </a:solidFill>
-              </a:defRPr>
-            </a:pPr>
-            <a:r>
-              <a:t>•  Step 2: Switch role to Dr. Twahir Mohammed -&gt; open patient workspace from queue.</a:t>
-            </a:r>
-          </a:p>
-          <a:p>
-            <a:pPr>
-              <a:spcAft>
-                <a:spcPts val="600"/>
-              </a:spcAft>
-              <a:defRPr sz="1200">
-                <a:solidFill>
-                  <a:srgbClr val="FFFFFF"/>
-                </a:solidFill>
-              </a:defRPr>
-            </a:pPr>
-            <a:r>
-              <a:t>•  Step 3: Record Clinical Consultation: Chief complaint = 'Sharp pain in lower right molar (Tooth #46)'.</a:t>
-            </a:r>
-          </a:p>
-          <a:p>
-            <a:pPr>
-              <a:spcAft>
-                <a:spcPts val="600"/>
-              </a:spcAft>
-              <a:defRPr sz="1200">
-                <a:solidFill>
-                  <a:srgbClr val="FFFFFF"/>
-                </a:solidFill>
-              </a:defRPr>
-            </a:pPr>
-            <a:r>
-              <a:t>•  Step 4: Navigate to 'X-rays &amp; AI Engine' -&gt; click 'Upload OPG X-Ray' -&gt; select panoramic radiograph from disk.</a:t>
-            </a:r>
-          </a:p>
-          <a:p>
-            <a:pPr>
-              <a:spcAft>
-                <a:spcPts val="600"/>
-              </a:spcAft>
-              <a:defRPr sz="1200">
-                <a:solidFill>
-                  <a:srgbClr val="FFFFFF"/>
-                </a:solidFill>
-              </a:defRPr>
-            </a:pPr>
-            <a:r>
-              <a:t>•  Step 5: Trigger AI Dental Analysis -&gt; YOLO11m executes in ~120ms -&gt; Bounding boxes render on canvas (Caries #46, Apical Lesion #46).</a:t>
-            </a:r>
-          </a:p>
-          <a:p>
-            <a:pPr>
-              <a:spcAft>
-                <a:spcPts val="600"/>
-              </a:spcAft>
-              <a:defRPr sz="1200">
-                <a:solidFill>
-                  <a:srgbClr val="FFFFFF"/>
-                </a:solidFill>
-              </a:defRPr>
-            </a:pPr>
-            <a:r>
-              <a:t>•  Step 6: Doctor confirms Caries finding on #46 -&gt; modifies notes -&gt; navigates to 'Diagnostic Reports'.</a:t>
-            </a:r>
-          </a:p>
-          <a:p>
-            <a:pPr>
-              <a:spcAft>
-                <a:spcPts val="600"/>
-              </a:spcAft>
-              <a:defRPr sz="1200">
-                <a:solidFill>
-                  <a:srgbClr val="FFFFFF"/>
-                </a:solidFill>
-              </a:defRPr>
-            </a:pPr>
-            <a:r>
-              <a:t>•  Step 7: Auto-compiled diagnostic report displays AI detections and doctor directives -&gt; print/export ready.</a:t>
-            </a:r>
-          </a:p>
-          <a:p>
-            <a:pPr>
-              <a:spcAft>
-                <a:spcPts val="600"/>
-              </a:spcAft>
-              <a:defRPr sz="1200">
-                <a:solidFill>
-                  <a:srgbClr val="FFFFFF"/>
-                </a:solidFill>
-              </a:defRPr>
-            </a:pPr>
-            <a:r>
-              <a:t>•  Step 8: Open 'History Timeline' -&gt; verify chronological event chain (Registration -&gt; Visit -&gt; X-ray -&gt; AI Analysis -&gt; Report).</a:t>
-            </a:r>
-          </a:p>
-        </p:txBody>
-      </p:sp>
+        </p:spPr>
+      </p:pic>
+      <p:pic>
+        <p:nvPicPr>
+          <p:cNvPr id="6" name="Picture 5" descr="screen_1_doctor_dashboard.png"/>
+          <p:cNvPicPr>
+            <a:picLocks noChangeAspect="1"/>
+          </p:cNvPicPr>
+          <p:nvPr/>
+        </p:nvPicPr>
+        <p:blipFill>
+          <a:blip r:embed="rId3"/>
+          <a:stretch>
+            <a:fillRect/>
+          </a:stretch>
+        </p:blipFill>
+        <p:spPr>
+          <a:xfrm>
+            <a:off x="6675120" y="1645920"/>
+            <a:ext cx="4754880" cy="2690787"/>
+          </a:xfrm>
+          <a:prstGeom prst="rect">
+            <a:avLst/>
+          </a:prstGeom>
+        </p:spPr>
+      </p:pic>
+      <p:pic>
+        <p:nvPicPr>
+          <p:cNvPr id="7" name="Picture 6" descr="screen_6_diagnostic_report.png"/>
+          <p:cNvPicPr>
+            <a:picLocks noChangeAspect="1"/>
+          </p:cNvPicPr>
+          <p:nvPr/>
+        </p:nvPicPr>
+        <p:blipFill>
+          <a:blip r:embed="rId4"/>
+          <a:stretch>
+            <a:fillRect/>
+          </a:stretch>
+        </p:blipFill>
+        <p:spPr>
+          <a:xfrm>
+            <a:off x="6675120" y="4114800"/>
+            <a:ext cx="4754880" cy="2690787"/>
+          </a:xfrm>
+          <a:prstGeom prst="rect">
+            <a:avLst/>
+          </a:prstGeom>
+        </p:spPr>
+      </p:pic>
     </p:spTree>
   </p:cSld>
   <p:clrMapOvr>
@@ -4231,7 +4101,7 @@
               </a:defRPr>
             </a:pPr>
             <a:r>
-              <a:t>Testing &amp; Verification Evidence</a:t>
+              <a:t>Demonstration Flow (Live Viva Walkthrough)</a:t>
             </a:r>
           </a:p>
         </p:txBody>
@@ -4245,7 +4115,7 @@
         <p:spPr>
           <a:xfrm>
             <a:off x="731520" y="1645920"/>
-            <a:ext cx="5120640" cy="4572000"/>
+            <a:ext cx="10698480" cy="4572000"/>
           </a:xfrm>
           <a:prstGeom prst="roundRect">
             <a:avLst/>
@@ -4290,7 +4160,7 @@
         <p:spPr>
           <a:xfrm>
             <a:off x="960120" y="1828800"/>
-            <a:ext cx="4663440" cy="4206240"/>
+            <a:ext cx="10241280" cy="4206240"/>
           </a:xfrm>
           <a:prstGeom prst="rect">
             <a:avLst/>
@@ -4314,225 +4184,127 @@
               </a:defRPr>
             </a:pPr>
             <a:r>
-              <a:t>Automated Test Suites</a:t>
-            </a:r>
-          </a:p>
-          <a:p>
-            <a:pPr>
-              <a:spcAft>
-                <a:spcPts val="600"/>
-              </a:spcAft>
-              <a:defRPr sz="1200">
-                <a:solidFill>
-                  <a:srgbClr val="FFFFFF"/>
-                </a:solidFill>
-              </a:defRPr>
-            </a:pPr>
-            <a:r>
-              <a:t>•  AI Service Test Suite: 23 passed, 0 failed via PyTest.</a:t>
-            </a:r>
-          </a:p>
-          <a:p>
-            <a:pPr>
-              <a:spcAft>
-                <a:spcPts val="600"/>
-              </a:spcAft>
-              <a:defRPr sz="1200">
-                <a:solidFill>
-                  <a:srgbClr val="FFFFFF"/>
-                </a:solidFill>
-              </a:defRPr>
-            </a:pPr>
-            <a:r>
-              <a:t>•  API Tests: Verified /health, /version, /analyze multipart uploads.</a:t>
-            </a:r>
-          </a:p>
-          <a:p>
-            <a:pPr>
-              <a:spcAft>
-                <a:spcPts val="600"/>
-              </a:spcAft>
-              <a:defRPr sz="1200">
-                <a:solidFill>
-                  <a:srgbClr val="FFFFFF"/>
-                </a:solidFill>
-              </a:defRPr>
-            </a:pPr>
-            <a:r>
-              <a:t>•  Inference &amp; Preprocessor Tests: Verified CLAHE, augmentations, and NMS suppression.</a:t>
-            </a:r>
-          </a:p>
-          <a:p>
-            <a:pPr>
-              <a:spcAft>
-                <a:spcPts val="600"/>
-              </a:spcAft>
-              <a:defRPr sz="1200">
-                <a:solidFill>
-                  <a:srgbClr val="FFFFFF"/>
-                </a:solidFill>
-              </a:defRPr>
-            </a:pPr>
-            <a:r>
-              <a:t>•  Backend Vitest Suite: 9/9 validation tests pass; health check integration test passes.</a:t>
-            </a:r>
-          </a:p>
-          <a:p>
-            <a:pPr>
-              <a:spcAft>
-                <a:spcPts val="600"/>
-              </a:spcAft>
-              <a:defRPr sz="1200">
-                <a:solidFill>
-                  <a:srgbClr val="FFFFFF"/>
-                </a:solidFill>
-              </a:defRPr>
-            </a:pPr>
-            <a:r>
-              <a:t>•  Desktop Production Bundle: Vite compiles 1,495 modules in 1.81s with 0 errors.</a:t>
-            </a:r>
-          </a:p>
-        </p:txBody>
-      </p:sp>
-      <p:sp>
-        <p:nvSpPr>
-          <p:cNvPr id="7" name="Rounded Rectangle 6"/>
-          <p:cNvSpPr/>
-          <p:nvPr/>
-        </p:nvSpPr>
-        <p:spPr>
-          <a:xfrm>
-            <a:off x="6217920" y="1645920"/>
-            <a:ext cx="5212080" cy="4572000"/>
-          </a:xfrm>
-          <a:prstGeom prst="roundRect">
-            <a:avLst/>
-          </a:prstGeom>
-          <a:solidFill>
-            <a:srgbClr val="1E293B"/>
-          </a:solidFill>
-          <a:ln w="12700">
-            <a:solidFill>
-              <a:srgbClr val="334155"/>
-            </a:solidFill>
-          </a:ln>
-        </p:spPr>
-        <p:style>
-          <a:lnRef idx="1">
-            <a:schemeClr val="accent1"/>
-          </a:lnRef>
-          <a:fillRef idx="3">
-            <a:schemeClr val="accent1"/>
-          </a:fillRef>
-          <a:effectRef idx="2">
-            <a:schemeClr val="accent1"/>
-          </a:effectRef>
-          <a:fontRef idx="minor">
-            <a:schemeClr val="lt1"/>
-          </a:fontRef>
-        </p:style>
-        <p:txBody>
-          <a:bodyPr rtlCol="0" anchor="ctr"/>
-          <a:lstStyle/>
-          <a:p>
-            <a:pPr algn="ctr"/>
-          </a:p>
-        </p:txBody>
-      </p:sp>
-      <p:sp>
-        <p:nvSpPr>
-          <p:cNvPr id="8" name="TextBox 7"/>
-          <p:cNvSpPr txBox="1"/>
-          <p:nvPr/>
-        </p:nvSpPr>
-        <p:spPr>
-          <a:xfrm>
-            <a:off x="6446520" y="1828800"/>
-            <a:ext cx="4754880" cy="4206240"/>
-          </a:xfrm>
-          <a:prstGeom prst="rect">
-            <a:avLst/>
-          </a:prstGeom>
-          <a:noFill/>
-        </p:spPr>
-        <p:txBody>
-          <a:bodyPr wrap="square">
-            <a:spAutoFit/>
-          </a:bodyPr>
-          <a:lstStyle/>
-          <a:p>
-            <a:pPr>
-              <a:spcAft>
-                <a:spcPts val="1000"/>
-              </a:spcAft>
-              <a:defRPr sz="1600" b="1">
-                <a:solidFill>
-                  <a:srgbClr val="06B6D4"/>
-                </a:solidFill>
-              </a:defRPr>
-            </a:pPr>
-            <a:r>
-              <a:t>Robustness &amp; Failure Handling</a:t>
-            </a:r>
-          </a:p>
-          <a:p>
-            <a:pPr>
-              <a:spcAft>
-                <a:spcPts val="600"/>
-              </a:spcAft>
-              <a:defRPr sz="1200">
-                <a:solidFill>
-                  <a:srgbClr val="FFFFFF"/>
-                </a:solidFill>
-              </a:defRPr>
-            </a:pPr>
-            <a:r>
-              <a:t>•  Graceful Fallback: OpenCV contour engine activates if model file is missing.</a:t>
-            </a:r>
-          </a:p>
-          <a:p>
-            <a:pPr>
-              <a:spcAft>
-                <a:spcPts val="600"/>
-              </a:spcAft>
-              <a:defRPr sz="1200">
-                <a:solidFill>
-                  <a:srgbClr val="FFFFFF"/>
-                </a:solidFill>
-              </a:defRPr>
-            </a:pPr>
-            <a:r>
-              <a:t>•  Network Disconnection: Desktop API client gracefully handles offline states without crashing.</a:t>
-            </a:r>
-          </a:p>
-          <a:p>
-            <a:pPr>
-              <a:spcAft>
-                <a:spcPts val="600"/>
-              </a:spcAft>
-              <a:defRPr sz="1200">
-                <a:solidFill>
-                  <a:srgbClr val="FFFFFF"/>
-                </a:solidFill>
-              </a:defRPr>
-            </a:pPr>
-            <a:r>
-              <a:t>•  Data Validation: Zod schemas validate phone, DOB, and clinical inputs.</a:t>
-            </a:r>
-          </a:p>
-          <a:p>
-            <a:pPr>
-              <a:spcAft>
-                <a:spcPts val="600"/>
-              </a:spcAft>
-              <a:defRPr sz="1200">
-                <a:solidFill>
-                  <a:srgbClr val="FFFFFF"/>
-                </a:solidFill>
-              </a:defRPr>
-            </a:pPr>
-            <a:r>
-              <a:t>•  Security: Helmet headers, CORS restrictions, JWT auth middleware.</a:t>
+              <a:t>Step-by-Step Clinical Demo Path</a:t>
+            </a:r>
+          </a:p>
+          <a:p>
+            <a:pPr>
+              <a:spcAft>
+                <a:spcPts val="600"/>
+              </a:spcAft>
+              <a:defRPr sz="1200">
+                <a:solidFill>
+                  <a:srgbClr val="FFFFFF"/>
+                </a:solidFill>
+              </a:defRPr>
+            </a:pPr>
+            <a:r>
+              <a:t>•  Step 1: Receptionist registers patient 'Amina Rahmani' (DOB: 1992-04-14, Medical Flag: Penicillin Allergy).</a:t>
+            </a:r>
+          </a:p>
+          <a:p>
+            <a:pPr>
+              <a:spcAft>
+                <a:spcPts val="600"/>
+              </a:spcAft>
+              <a:defRPr sz="1200">
+                <a:solidFill>
+                  <a:srgbClr val="FFFFFF"/>
+                </a:solidFill>
+              </a:defRPr>
+            </a:pPr>
+            <a:r>
+              <a:t>•  Step 2: Switch role to Dr. Twahir Mohammed -&gt; open patient workspace from queue.</a:t>
+            </a:r>
+          </a:p>
+          <a:p>
+            <a:pPr>
+              <a:spcAft>
+                <a:spcPts val="600"/>
+              </a:spcAft>
+              <a:defRPr sz="1200">
+                <a:solidFill>
+                  <a:srgbClr val="FFFFFF"/>
+                </a:solidFill>
+              </a:defRPr>
+            </a:pPr>
+            <a:r>
+              <a:t>•  Step 3: Record Clinical Consultation: Chief complaint = 'Sharp pain in lower right molar (Tooth #46)'.</a:t>
+            </a:r>
+          </a:p>
+          <a:p>
+            <a:pPr>
+              <a:spcAft>
+                <a:spcPts val="600"/>
+              </a:spcAft>
+              <a:defRPr sz="1200">
+                <a:solidFill>
+                  <a:srgbClr val="FFFFFF"/>
+                </a:solidFill>
+              </a:defRPr>
+            </a:pPr>
+            <a:r>
+              <a:t>•  Step 4: Navigate to 'X-rays &amp; AI Engine' -&gt; click 'Upload OPG X-Ray' -&gt; select panoramic radiograph from disk.</a:t>
+            </a:r>
+          </a:p>
+          <a:p>
+            <a:pPr>
+              <a:spcAft>
+                <a:spcPts val="600"/>
+              </a:spcAft>
+              <a:defRPr sz="1200">
+                <a:solidFill>
+                  <a:srgbClr val="FFFFFF"/>
+                </a:solidFill>
+              </a:defRPr>
+            </a:pPr>
+            <a:r>
+              <a:t>•  Step 5: Trigger AI Dental Analysis -&gt; YOLO11m executes native tiling + WBF in ~746ms -&gt; Bounding boxes render on canvas.</a:t>
+            </a:r>
+          </a:p>
+          <a:p>
+            <a:pPr>
+              <a:spcAft>
+                <a:spcPts val="600"/>
+              </a:spcAft>
+              <a:defRPr sz="1200">
+                <a:solidFill>
+                  <a:srgbClr val="FFFFFF"/>
+                </a:solidFill>
+              </a:defRPr>
+            </a:pPr>
+            <a:r>
+              <a:t>•  Step 6: Doctor confirms Caries finding on #15 / Obturation on #31 -&gt; modifies notes -&gt; navigates to 'Diagnostic Reports'.</a:t>
+            </a:r>
+          </a:p>
+          <a:p>
+            <a:pPr>
+              <a:spcAft>
+                <a:spcPts val="600"/>
+              </a:spcAft>
+              <a:defRPr sz="1200">
+                <a:solidFill>
+                  <a:srgbClr val="FFFFFF"/>
+                </a:solidFill>
+              </a:defRPr>
+            </a:pPr>
+            <a:r>
+              <a:t>•  Step 7: Auto-compiled diagnostic report displays AI detections and doctor directives -&gt; print/export ready.</a:t>
+            </a:r>
+          </a:p>
+          <a:p>
+            <a:pPr>
+              <a:spcAft>
+                <a:spcPts val="600"/>
+              </a:spcAft>
+              <a:defRPr sz="1200">
+                <a:solidFill>
+                  <a:srgbClr val="FFFFFF"/>
+                </a:solidFill>
+              </a:defRPr>
+            </a:pPr>
+            <a:r>
+              <a:t>•  Step 8: Open 'History Timeline' -&gt; verify chronological event chain (Registration -&gt; Visit -&gt; X-ray -&gt; AI Analysis -&gt; Report).</a:t>
             </a:r>
           </a:p>
         </p:txBody>
@@ -4665,7 +4437,7 @@
               </a:defRPr>
             </a:pPr>
             <a:r>
-              <a:t>Current Limitations &amp; Future Scope</a:t>
+              <a:t>Testing &amp; Verification Evidence</a:t>
             </a:r>
           </a:p>
         </p:txBody>
@@ -4748,67 +4520,82 @@
               </a:defRPr>
             </a:pPr>
             <a:r>
-              <a:t>Honest Technical Limitations</a:t>
-            </a:r>
-          </a:p>
-          <a:p>
-            <a:pPr>
-              <a:spcAft>
-                <a:spcPts val="600"/>
-              </a:spcAft>
-              <a:defRPr sz="1200">
-                <a:solidFill>
-                  <a:srgbClr val="FFFFFF"/>
-                </a:solidFill>
-              </a:defRPr>
-            </a:pPr>
-            <a:r>
-              <a:t>•  Superimposed Jaw Anatomy: Ghost shadows from cervical spine occasionally cause spurious low-confidence detections.</a:t>
-            </a:r>
-          </a:p>
-          <a:p>
-            <a:pPr>
-              <a:spcAft>
-                <a:spcPts val="600"/>
-              </a:spcAft>
-              <a:defRPr sz="1200">
-                <a:solidFill>
-                  <a:srgbClr val="FFFFFF"/>
-                </a:solidFill>
-              </a:defRPr>
-            </a:pPr>
-            <a:r>
-              <a:t>•  Micro-Caries Sensitivity: Incipient enamel-only caries (&lt;10px) remain challenging on lower-resolution scans.</a:t>
-            </a:r>
-          </a:p>
-          <a:p>
-            <a:pPr>
-              <a:spcAft>
-                <a:spcPts val="600"/>
-              </a:spcAft>
-              <a:defRPr sz="1200">
-                <a:solidFill>
-                  <a:srgbClr val="FFFFFF"/>
-                </a:solidFill>
-              </a:defRPr>
-            </a:pPr>
-            <a:r>
-              <a:t>•  Diffuse Bone Resorption: Horizontal alveolar crest reduction lacks sharp edges, requiring clinician verification.</a:t>
-            </a:r>
-          </a:p>
-          <a:p>
-            <a:pPr>
-              <a:spcAft>
-                <a:spcPts val="600"/>
-              </a:spcAft>
-              <a:defRPr sz="1200">
-                <a:solidFill>
-                  <a:srgbClr val="FFFFFF"/>
-                </a:solidFill>
-              </a:defRPr>
-            </a:pPr>
-            <a:r>
-              <a:t>•  2D vs 3D Modality: Panoramic 2D scans cannot measure buccolingual bone depth.</a:t>
+              <a:t>Automated Test Suites</a:t>
+            </a:r>
+          </a:p>
+          <a:p>
+            <a:pPr>
+              <a:spcAft>
+                <a:spcPts val="600"/>
+              </a:spcAft>
+              <a:defRPr sz="1200">
+                <a:solidFill>
+                  <a:srgbClr val="FFFFFF"/>
+                </a:solidFill>
+              </a:defRPr>
+            </a:pPr>
+            <a:r>
+              <a:t>•  AI Service Test Suite: 23 passed, 0 failed via PyTest.</a:t>
+            </a:r>
+          </a:p>
+          <a:p>
+            <a:pPr>
+              <a:spcAft>
+                <a:spcPts val="600"/>
+              </a:spcAft>
+              <a:defRPr sz="1200">
+                <a:solidFill>
+                  <a:srgbClr val="FFFFFF"/>
+                </a:solidFill>
+              </a:defRPr>
+            </a:pPr>
+            <a:r>
+              <a:t>•  API Tests: Verified /health, /version, /analyze multipart uploads.</a:t>
+            </a:r>
+          </a:p>
+          <a:p>
+            <a:pPr>
+              <a:spcAft>
+                <a:spcPts val="600"/>
+              </a:spcAft>
+              <a:defRPr sz="1200">
+                <a:solidFill>
+                  <a:srgbClr val="FFFFFF"/>
+                </a:solidFill>
+              </a:defRPr>
+            </a:pPr>
+            <a:r>
+              <a:t>•  Inference &amp; Preprocessor Tests: Verified CLAHE, augmentations, and NMS suppression.</a:t>
+            </a:r>
+          </a:p>
+          <a:p>
+            <a:pPr>
+              <a:spcAft>
+                <a:spcPts val="600"/>
+              </a:spcAft>
+              <a:defRPr sz="1200">
+                <a:solidFill>
+                  <a:srgbClr val="FFFFFF"/>
+                </a:solidFill>
+              </a:defRPr>
+            </a:pPr>
+            <a:r>
+              <a:t>•  Backend Vitest Suite: 9/9 validation tests pass; health check integration test passes.</a:t>
+            </a:r>
+          </a:p>
+          <a:p>
+            <a:pPr>
+              <a:spcAft>
+                <a:spcPts val="600"/>
+              </a:spcAft>
+              <a:defRPr sz="1200">
+                <a:solidFill>
+                  <a:srgbClr val="FFFFFF"/>
+                </a:solidFill>
+              </a:defRPr>
+            </a:pPr>
+            <a:r>
+              <a:t>•  Desktop Production Bundle: Vite compiles 1,495 modules in 1.81s with 0 errors.</a:t>
             </a:r>
           </a:p>
         </p:txBody>
@@ -4891,67 +4678,67 @@
               </a:defRPr>
             </a:pPr>
             <a:r>
-              <a:t>Future Scope (Version 2.0)</a:t>
-            </a:r>
-          </a:p>
-          <a:p>
-            <a:pPr>
-              <a:spcAft>
-                <a:spcPts val="600"/>
-              </a:spcAft>
-              <a:defRPr sz="1200">
-                <a:solidFill>
-                  <a:srgbClr val="FFFFFF"/>
-                </a:solidFill>
-              </a:defRPr>
-            </a:pPr>
-            <a:r>
-              <a:t>•  CBCT 3D Volumetric Segmentation: Multi-planar reconstruction for implant planning.</a:t>
-            </a:r>
-          </a:p>
-          <a:p>
-            <a:pPr>
-              <a:spcAft>
-                <a:spcPts val="600"/>
-              </a:spcAft>
-              <a:defRPr sz="1200">
-                <a:solidFill>
-                  <a:srgbClr val="FFFFFF"/>
-                </a:solidFill>
-              </a:defRPr>
-            </a:pPr>
-            <a:r>
-              <a:t>•  Voice-Assisted Dictation: Speech-to-text clinical consultation logging.</a:t>
-            </a:r>
-          </a:p>
-          <a:p>
-            <a:pPr>
-              <a:spcAft>
-                <a:spcPts val="600"/>
-              </a:spcAft>
-              <a:defRPr sz="1200">
-                <a:solidFill>
-                  <a:srgbClr val="FFFFFF"/>
-                </a:solidFill>
-              </a:defRPr>
-            </a:pPr>
-            <a:r>
-              <a:t>•  Tooth Segmentation Masks: Instance segmentation (YOLO11-seg) for exact crown/root boundaries.</a:t>
-            </a:r>
-          </a:p>
-          <a:p>
-            <a:pPr>
-              <a:spcAft>
-                <a:spcPts val="600"/>
-              </a:spcAft>
-              <a:defRPr sz="1200">
-                <a:solidFill>
-                  <a:srgbClr val="FFFFFF"/>
-                </a:solidFill>
-              </a:defRPr>
-            </a:pPr>
-            <a:r>
-              <a:t>•  Mobile Patient Portal: Progressive Web App (PWA) for patient appointment viewing.</a:t>
+              <a:t>Robustness &amp; Failure Handling</a:t>
+            </a:r>
+          </a:p>
+          <a:p>
+            <a:pPr>
+              <a:spcAft>
+                <a:spcPts val="600"/>
+              </a:spcAft>
+              <a:defRPr sz="1200">
+                <a:solidFill>
+                  <a:srgbClr val="FFFFFF"/>
+                </a:solidFill>
+              </a:defRPr>
+            </a:pPr>
+            <a:r>
+              <a:t>•  Graceful Fallback: Dual-gateway client falls back directly to local FastAPI if database is offline.</a:t>
+            </a:r>
+          </a:p>
+          <a:p>
+            <a:pPr>
+              <a:spcAft>
+                <a:spcPts val="600"/>
+              </a:spcAft>
+              <a:defRPr sz="1200">
+                <a:solidFill>
+                  <a:srgbClr val="FFFFFF"/>
+                </a:solidFill>
+              </a:defRPr>
+            </a:pPr>
+            <a:r>
+              <a:t>•  Network Disconnection: Desktop API client gracefully handles offline states without crashing.</a:t>
+            </a:r>
+          </a:p>
+          <a:p>
+            <a:pPr>
+              <a:spcAft>
+                <a:spcPts val="600"/>
+              </a:spcAft>
+              <a:defRPr sz="1200">
+                <a:solidFill>
+                  <a:srgbClr val="FFFFFF"/>
+                </a:solidFill>
+              </a:defRPr>
+            </a:pPr>
+            <a:r>
+              <a:t>•  Data Validation: Zod schemas validate phone, DOB, and clinical inputs.</a:t>
+            </a:r>
+          </a:p>
+          <a:p>
+            <a:pPr>
+              <a:spcAft>
+                <a:spcPts val="600"/>
+              </a:spcAft>
+              <a:defRPr sz="1200">
+                <a:solidFill>
+                  <a:srgbClr val="FFFFFF"/>
+                </a:solidFill>
+              </a:defRPr>
+            </a:pPr>
+            <a:r>
+              <a:t>•  Security: Helmet headers, CORS restrictions, JWT auth middleware.</a:t>
             </a:r>
           </a:p>
         </p:txBody>
@@ -4965,6 +4752,425 @@
 </file>
 
 <file path=ppt/slides/slide14.xml><?xml version="1.0" encoding="utf-8"?>
+<p:sld xmlns:a="http://schemas.openxmlformats.org/drawingml/2006/main" xmlns:p="http://schemas.openxmlformats.org/presentationml/2006/main" xmlns:r="http://schemas.openxmlformats.org/officeDocument/2006/relationships">
+  <p:cSld>
+    <p:spTree>
+      <p:nvGrpSpPr>
+        <p:cNvPr id="1" name=""/>
+        <p:cNvGrpSpPr/>
+        <p:nvPr/>
+      </p:nvGrpSpPr>
+      <p:grpSpPr/>
+      <p:sp>
+        <p:nvSpPr>
+          <p:cNvPr id="2" name="Rectangle 1"/>
+          <p:cNvSpPr/>
+          <p:nvPr/>
+        </p:nvSpPr>
+        <p:spPr>
+          <a:xfrm>
+            <a:off x="0" y="0"/>
+            <a:ext cx="12191695" cy="6858000"/>
+          </a:xfrm>
+          <a:prstGeom prst="rect">
+            <a:avLst/>
+          </a:prstGeom>
+          <a:solidFill>
+            <a:srgbClr val="0F172A"/>
+          </a:solidFill>
+          <a:ln>
+            <a:solidFill>
+              <a:srgbClr val="0F172A"/>
+            </a:solidFill>
+          </a:ln>
+        </p:spPr>
+        <p:style>
+          <a:lnRef idx="1">
+            <a:schemeClr val="accent1"/>
+          </a:lnRef>
+          <a:fillRef idx="3">
+            <a:schemeClr val="accent1"/>
+          </a:fillRef>
+          <a:effectRef idx="2">
+            <a:schemeClr val="accent1"/>
+          </a:effectRef>
+          <a:fontRef idx="minor">
+            <a:schemeClr val="lt1"/>
+          </a:fontRef>
+        </p:style>
+        <p:txBody>
+          <a:bodyPr rtlCol="0" anchor="ctr"/>
+          <a:lstStyle/>
+          <a:p>
+            <a:pPr algn="ctr"/>
+          </a:p>
+        </p:txBody>
+      </p:sp>
+      <p:sp>
+        <p:nvSpPr>
+          <p:cNvPr id="3" name="TextBox 2"/>
+          <p:cNvSpPr txBox="1"/>
+          <p:nvPr/>
+        </p:nvSpPr>
+        <p:spPr>
+          <a:xfrm>
+            <a:off x="731520" y="365760"/>
+            <a:ext cx="10515600" cy="365760"/>
+          </a:xfrm>
+          <a:prstGeom prst="rect">
+            <a:avLst/>
+          </a:prstGeom>
+          <a:noFill/>
+        </p:spPr>
+        <p:txBody>
+          <a:bodyPr wrap="square">
+            <a:spAutoFit/>
+          </a:bodyPr>
+          <a:lstStyle/>
+          <a:p>
+            <a:pPr>
+              <a:defRPr sz="1100" b="1">
+                <a:solidFill>
+                  <a:srgbClr val="14B8A6"/>
+                </a:solidFill>
+              </a:defRPr>
+            </a:pPr>
+            <a:r>
+              <a:t>DENTAVISION AI — FINAL YEAR MAJOR PROJECT</a:t>
+            </a:r>
+          </a:p>
+        </p:txBody>
+      </p:sp>
+      <p:sp>
+        <p:nvSpPr>
+          <p:cNvPr id="4" name="TextBox 3"/>
+          <p:cNvSpPr txBox="1"/>
+          <p:nvPr/>
+        </p:nvSpPr>
+        <p:spPr>
+          <a:xfrm>
+            <a:off x="731520" y="640080"/>
+            <a:ext cx="10515600" cy="731520"/>
+          </a:xfrm>
+          <a:prstGeom prst="rect">
+            <a:avLst/>
+          </a:prstGeom>
+          <a:noFill/>
+        </p:spPr>
+        <p:txBody>
+          <a:bodyPr wrap="square">
+            <a:spAutoFit/>
+          </a:bodyPr>
+          <a:lstStyle/>
+          <a:p>
+            <a:pPr>
+              <a:defRPr sz="2400" b="1">
+                <a:solidFill>
+                  <a:srgbClr val="FFFFFF"/>
+                </a:solidFill>
+              </a:defRPr>
+            </a:pPr>
+            <a:r>
+              <a:t>Current Limitations &amp; Future Scope</a:t>
+            </a:r>
+          </a:p>
+        </p:txBody>
+      </p:sp>
+      <p:sp>
+        <p:nvSpPr>
+          <p:cNvPr id="5" name="Rounded Rectangle 4"/>
+          <p:cNvSpPr/>
+          <p:nvPr/>
+        </p:nvSpPr>
+        <p:spPr>
+          <a:xfrm>
+            <a:off x="731520" y="1645920"/>
+            <a:ext cx="5120640" cy="4572000"/>
+          </a:xfrm>
+          <a:prstGeom prst="roundRect">
+            <a:avLst/>
+          </a:prstGeom>
+          <a:solidFill>
+            <a:srgbClr val="1E293B"/>
+          </a:solidFill>
+          <a:ln w="12700">
+            <a:solidFill>
+              <a:srgbClr val="334155"/>
+            </a:solidFill>
+          </a:ln>
+        </p:spPr>
+        <p:style>
+          <a:lnRef idx="1">
+            <a:schemeClr val="accent1"/>
+          </a:lnRef>
+          <a:fillRef idx="3">
+            <a:schemeClr val="accent1"/>
+          </a:fillRef>
+          <a:effectRef idx="2">
+            <a:schemeClr val="accent1"/>
+          </a:effectRef>
+          <a:fontRef idx="minor">
+            <a:schemeClr val="lt1"/>
+          </a:fontRef>
+        </p:style>
+        <p:txBody>
+          <a:bodyPr rtlCol="0" anchor="ctr"/>
+          <a:lstStyle/>
+          <a:p>
+            <a:pPr algn="ctr"/>
+          </a:p>
+        </p:txBody>
+      </p:sp>
+      <p:sp>
+        <p:nvSpPr>
+          <p:cNvPr id="6" name="TextBox 5"/>
+          <p:cNvSpPr txBox="1"/>
+          <p:nvPr/>
+        </p:nvSpPr>
+        <p:spPr>
+          <a:xfrm>
+            <a:off x="960120" y="1828800"/>
+            <a:ext cx="4663440" cy="4206240"/>
+          </a:xfrm>
+          <a:prstGeom prst="rect">
+            <a:avLst/>
+          </a:prstGeom>
+          <a:noFill/>
+        </p:spPr>
+        <p:txBody>
+          <a:bodyPr wrap="square">
+            <a:spAutoFit/>
+          </a:bodyPr>
+          <a:lstStyle/>
+          <a:p>
+            <a:pPr>
+              <a:spcAft>
+                <a:spcPts val="1000"/>
+              </a:spcAft>
+              <a:defRPr sz="1600" b="1">
+                <a:solidFill>
+                  <a:srgbClr val="06B6D4"/>
+                </a:solidFill>
+              </a:defRPr>
+            </a:pPr>
+            <a:r>
+              <a:t>Honest Technical Limitations</a:t>
+            </a:r>
+          </a:p>
+          <a:p>
+            <a:pPr>
+              <a:spcAft>
+                <a:spcPts val="600"/>
+              </a:spcAft>
+              <a:defRPr sz="1200">
+                <a:solidFill>
+                  <a:srgbClr val="FFFFFF"/>
+                </a:solidFill>
+              </a:defRPr>
+            </a:pPr>
+            <a:r>
+              <a:t>•  Superimposed Jaw Anatomy: Ghost shadows from cervical spine occasionally cause spurious low-confidence detections.</a:t>
+            </a:r>
+          </a:p>
+          <a:p>
+            <a:pPr>
+              <a:spcAft>
+                <a:spcPts val="600"/>
+              </a:spcAft>
+              <a:defRPr sz="1200">
+                <a:solidFill>
+                  <a:srgbClr val="FFFFFF"/>
+                </a:solidFill>
+              </a:defRPr>
+            </a:pPr>
+            <a:r>
+              <a:t>•  Micro-Caries Sensitivity: Incipient enamel-only caries (&lt;10px) remain challenging on lower-resolution scans.</a:t>
+            </a:r>
+          </a:p>
+          <a:p>
+            <a:pPr>
+              <a:spcAft>
+                <a:spcPts val="600"/>
+              </a:spcAft>
+              <a:defRPr sz="1200">
+                <a:solidFill>
+                  <a:srgbClr val="FFFFFF"/>
+                </a:solidFill>
+              </a:defRPr>
+            </a:pPr>
+            <a:r>
+              <a:t>•  Diffuse Bone Resorption: Horizontal alveolar crest reduction lacks sharp edges, requiring clinician verification.</a:t>
+            </a:r>
+          </a:p>
+          <a:p>
+            <a:pPr>
+              <a:spcAft>
+                <a:spcPts val="600"/>
+              </a:spcAft>
+              <a:defRPr sz="1200">
+                <a:solidFill>
+                  <a:srgbClr val="FFFFFF"/>
+                </a:solidFill>
+              </a:defRPr>
+            </a:pPr>
+            <a:r>
+              <a:t>•  2D vs 3D Modality: Panoramic 2D scans cannot measure buccolingual bone depth.</a:t>
+            </a:r>
+          </a:p>
+        </p:txBody>
+      </p:sp>
+      <p:sp>
+        <p:nvSpPr>
+          <p:cNvPr id="7" name="Rounded Rectangle 6"/>
+          <p:cNvSpPr/>
+          <p:nvPr/>
+        </p:nvSpPr>
+        <p:spPr>
+          <a:xfrm>
+            <a:off x="6217920" y="1645920"/>
+            <a:ext cx="5212080" cy="4572000"/>
+          </a:xfrm>
+          <a:prstGeom prst="roundRect">
+            <a:avLst/>
+          </a:prstGeom>
+          <a:solidFill>
+            <a:srgbClr val="1E293B"/>
+          </a:solidFill>
+          <a:ln w="12700">
+            <a:solidFill>
+              <a:srgbClr val="334155"/>
+            </a:solidFill>
+          </a:ln>
+        </p:spPr>
+        <p:style>
+          <a:lnRef idx="1">
+            <a:schemeClr val="accent1"/>
+          </a:lnRef>
+          <a:fillRef idx="3">
+            <a:schemeClr val="accent1"/>
+          </a:fillRef>
+          <a:effectRef idx="2">
+            <a:schemeClr val="accent1"/>
+          </a:effectRef>
+          <a:fontRef idx="minor">
+            <a:schemeClr val="lt1"/>
+          </a:fontRef>
+        </p:style>
+        <p:txBody>
+          <a:bodyPr rtlCol="0" anchor="ctr"/>
+          <a:lstStyle/>
+          <a:p>
+            <a:pPr algn="ctr"/>
+          </a:p>
+        </p:txBody>
+      </p:sp>
+      <p:sp>
+        <p:nvSpPr>
+          <p:cNvPr id="8" name="TextBox 7"/>
+          <p:cNvSpPr txBox="1"/>
+          <p:nvPr/>
+        </p:nvSpPr>
+        <p:spPr>
+          <a:xfrm>
+            <a:off x="6446520" y="1828800"/>
+            <a:ext cx="4754880" cy="4206240"/>
+          </a:xfrm>
+          <a:prstGeom prst="rect">
+            <a:avLst/>
+          </a:prstGeom>
+          <a:noFill/>
+        </p:spPr>
+        <p:txBody>
+          <a:bodyPr wrap="square">
+            <a:spAutoFit/>
+          </a:bodyPr>
+          <a:lstStyle/>
+          <a:p>
+            <a:pPr>
+              <a:spcAft>
+                <a:spcPts val="1000"/>
+              </a:spcAft>
+              <a:defRPr sz="1600" b="1">
+                <a:solidFill>
+                  <a:srgbClr val="06B6D4"/>
+                </a:solidFill>
+              </a:defRPr>
+            </a:pPr>
+            <a:r>
+              <a:t>Future Scope (Version 2.0)</a:t>
+            </a:r>
+          </a:p>
+          <a:p>
+            <a:pPr>
+              <a:spcAft>
+                <a:spcPts val="600"/>
+              </a:spcAft>
+              <a:defRPr sz="1200">
+                <a:solidFill>
+                  <a:srgbClr val="FFFFFF"/>
+                </a:solidFill>
+              </a:defRPr>
+            </a:pPr>
+            <a:r>
+              <a:t>•  CBCT 3D Volumetric Segmentation: Multi-planar reconstruction for implant planning.</a:t>
+            </a:r>
+          </a:p>
+          <a:p>
+            <a:pPr>
+              <a:spcAft>
+                <a:spcPts val="600"/>
+              </a:spcAft>
+              <a:defRPr sz="1200">
+                <a:solidFill>
+                  <a:srgbClr val="FFFFFF"/>
+                </a:solidFill>
+              </a:defRPr>
+            </a:pPr>
+            <a:r>
+              <a:t>•  Voice-Assisted Dictation: Speech-to-text clinical consultation logging.</a:t>
+            </a:r>
+          </a:p>
+          <a:p>
+            <a:pPr>
+              <a:spcAft>
+                <a:spcPts val="600"/>
+              </a:spcAft>
+              <a:defRPr sz="1200">
+                <a:solidFill>
+                  <a:srgbClr val="FFFFFF"/>
+                </a:solidFill>
+              </a:defRPr>
+            </a:pPr>
+            <a:r>
+              <a:t>•  Tooth Segmentation Masks: Instance segmentation (YOLO11-seg) for exact crown/root boundaries.</a:t>
+            </a:r>
+          </a:p>
+          <a:p>
+            <a:pPr>
+              <a:spcAft>
+                <a:spcPts val="600"/>
+              </a:spcAft>
+              <a:defRPr sz="1200">
+                <a:solidFill>
+                  <a:srgbClr val="FFFFFF"/>
+                </a:solidFill>
+              </a:defRPr>
+            </a:pPr>
+            <a:r>
+              <a:t>•  Mobile Patient Portal: Progressive Web App (PWA) for patient appointment viewing.</a:t>
+            </a:r>
+          </a:p>
+        </p:txBody>
+      </p:sp>
+    </p:spTree>
+  </p:cSld>
+  <p:clrMapOvr>
+    <a:masterClrMapping/>
+  </p:clrMapOvr>
+</p:sld>
+</file>
+
+<file path=ppt/slides/slide15.xml><?xml version="1.0" encoding="utf-8"?>
 <p:sld xmlns:a="http://schemas.openxmlformats.org/drawingml/2006/main" xmlns:p="http://schemas.openxmlformats.org/presentationml/2006/main" xmlns:r="http://schemas.openxmlformats.org/officeDocument/2006/relationships">
   <p:cSld>
     <p:spTree>

</xml_diff>